<commit_message>
Done with all parts
</commit_message>
<xml_diff>
--- a/ece313_sp26_project_task_2.pptx
+++ b/ece313_sp26_project_task_2.pptx
@@ -13,6 +13,7 @@
     <p:sldId id="261" r:id="rId10"/>
     <p:sldId id="262" r:id="rId11"/>
     <p:sldId id="263" r:id="rId12"/>
+    <p:sldId id="264" r:id="rId13"/>
   </p:sldIdLst>
   <p:sldSz cx="12192000" cy="6858000"/>
   <p:notesSz cx="6858000" cy="9144000"/>
@@ -266,7 +267,7 @@
           <a:p>
             <a:fld id="{A53BDE92-B6C1-B841-AFA7-BDBE3399A1A6}" type="datetimeFigureOut">
               <a:rPr lang="en-US" smtClean="0"/>
-              <a:t>4/7/2026</a:t>
+              <a:t>4/9/26</a:t>
             </a:fld>
             <a:endParaRPr lang="en-US"/>
           </a:p>
@@ -464,7 +465,7 @@
           <a:p>
             <a:fld id="{A53BDE92-B6C1-B841-AFA7-BDBE3399A1A6}" type="datetimeFigureOut">
               <a:rPr lang="en-US" smtClean="0"/>
-              <a:t>4/7/2026</a:t>
+              <a:t>4/9/26</a:t>
             </a:fld>
             <a:endParaRPr lang="en-US"/>
           </a:p>
@@ -672,7 +673,7 @@
           <a:p>
             <a:fld id="{A53BDE92-B6C1-B841-AFA7-BDBE3399A1A6}" type="datetimeFigureOut">
               <a:rPr lang="en-US" smtClean="0"/>
-              <a:t>4/7/2026</a:t>
+              <a:t>4/9/26</a:t>
             </a:fld>
             <a:endParaRPr lang="en-US"/>
           </a:p>
@@ -870,7 +871,7 @@
           <a:p>
             <a:fld id="{A53BDE92-B6C1-B841-AFA7-BDBE3399A1A6}" type="datetimeFigureOut">
               <a:rPr lang="en-US" smtClean="0"/>
-              <a:t>4/7/2026</a:t>
+              <a:t>4/9/26</a:t>
             </a:fld>
             <a:endParaRPr lang="en-US"/>
           </a:p>
@@ -1145,7 +1146,7 @@
           <a:p>
             <a:fld id="{A53BDE92-B6C1-B841-AFA7-BDBE3399A1A6}" type="datetimeFigureOut">
               <a:rPr lang="en-US" smtClean="0"/>
-              <a:t>4/7/2026</a:t>
+              <a:t>4/9/26</a:t>
             </a:fld>
             <a:endParaRPr lang="en-US"/>
           </a:p>
@@ -1410,7 +1411,7 @@
           <a:p>
             <a:fld id="{A53BDE92-B6C1-B841-AFA7-BDBE3399A1A6}" type="datetimeFigureOut">
               <a:rPr lang="en-US" smtClean="0"/>
-              <a:t>4/7/2026</a:t>
+              <a:t>4/9/26</a:t>
             </a:fld>
             <a:endParaRPr lang="en-US"/>
           </a:p>
@@ -1822,7 +1823,7 @@
           <a:p>
             <a:fld id="{A53BDE92-B6C1-B841-AFA7-BDBE3399A1A6}" type="datetimeFigureOut">
               <a:rPr lang="en-US" smtClean="0"/>
-              <a:t>4/7/2026</a:t>
+              <a:t>4/9/26</a:t>
             </a:fld>
             <a:endParaRPr lang="en-US"/>
           </a:p>
@@ -1963,7 +1964,7 @@
           <a:p>
             <a:fld id="{A53BDE92-B6C1-B841-AFA7-BDBE3399A1A6}" type="datetimeFigureOut">
               <a:rPr lang="en-US" smtClean="0"/>
-              <a:t>4/7/2026</a:t>
+              <a:t>4/9/26</a:t>
             </a:fld>
             <a:endParaRPr lang="en-US"/>
           </a:p>
@@ -2076,7 +2077,7 @@
           <a:p>
             <a:fld id="{A53BDE92-B6C1-B841-AFA7-BDBE3399A1A6}" type="datetimeFigureOut">
               <a:rPr lang="en-US" smtClean="0"/>
-              <a:t>4/7/2026</a:t>
+              <a:t>4/9/26</a:t>
             </a:fld>
             <a:endParaRPr lang="en-US"/>
           </a:p>
@@ -2387,7 +2388,7 @@
           <a:p>
             <a:fld id="{A53BDE92-B6C1-B841-AFA7-BDBE3399A1A6}" type="datetimeFigureOut">
               <a:rPr lang="en-US" smtClean="0"/>
-              <a:t>4/7/2026</a:t>
+              <a:t>4/9/26</a:t>
             </a:fld>
             <a:endParaRPr lang="en-US"/>
           </a:p>
@@ -2675,7 +2676,7 @@
           <a:p>
             <a:fld id="{A53BDE92-B6C1-B841-AFA7-BDBE3399A1A6}" type="datetimeFigureOut">
               <a:rPr lang="en-US" smtClean="0"/>
-              <a:t>4/7/2026</a:t>
+              <a:t>4/9/26</a:t>
             </a:fld>
             <a:endParaRPr lang="en-US"/>
           </a:p>
@@ -2916,7 +2917,7 @@
           <a:p>
             <a:fld id="{A53BDE92-B6C1-B841-AFA7-BDBE3399A1A6}" type="datetimeFigureOut">
               <a:rPr lang="en-US" smtClean="0"/>
-              <a:t>4/7/2026</a:t>
+              <a:t>4/9/26</a:t>
             </a:fld>
             <a:endParaRPr lang="en-US"/>
           </a:p>
@@ -3397,13 +3398,21 @@
           <a:p>
             <a:r>
               <a:rPr lang="en-US" dirty="0"/>
-              <a:t>&lt;NetID 1, NetID 2, NetID 3&gt;</a:t>
+              <a:t>&lt;dhruvv4 , vmagow2, bkeating2&gt;</a:t>
             </a:r>
           </a:p>
           <a:p>
             <a:r>
               <a:rPr lang="en-US" dirty="0"/>
-              <a:t>&lt;Name 1, Name 2, Name 3&gt;</a:t>
+              <a:t>&lt;Dhruv Vohra, Vedaant </a:t>
+            </a:r>
+            <a:r>
+              <a:rPr lang="en-US" dirty="0" err="1"/>
+              <a:t>Magow</a:t>
+            </a:r>
+            <a:r>
+              <a:rPr lang="en-US" dirty="0"/>
+              <a:t>, Brian Keating&gt;</a:t>
             </a:r>
           </a:p>
         </p:txBody>
@@ -3917,7 +3926,9 @@
         </p:nvSpPr>
         <p:spPr/>
         <p:txBody>
-          <a:bodyPr/>
+          <a:bodyPr>
+            <a:normAutofit fontScale="92500" lnSpcReduction="20000"/>
+          </a:bodyPr>
           <a:lstStyle/>
           <a:p>
             <a:r>
@@ -3926,9 +3937,25 @@
             </a:r>
           </a:p>
           <a:p>
-            <a:pPr marL="0" indent="0">
+            <a:pPr marL="0" indent="0" algn="l">
               <a:buNone/>
             </a:pPr>
+            <a:endParaRPr lang="en-US" b="0" i="0" dirty="0">
+              <a:effectLst/>
+              <a:latin typeface="Menlo" panose="020B0609030804020204" pitchFamily="49" charset="0"/>
+            </a:endParaRPr>
+          </a:p>
+          <a:p>
+            <a:pPr marL="0" indent="0" algn="l">
+              <a:buNone/>
+            </a:pPr>
+            <a:r>
+              <a:rPr lang="en-US" b="0" i="0" dirty="0">
+                <a:effectLst/>
+                <a:latin typeface="Menlo" panose="020B0609030804020204" pitchFamily="49" charset="0"/>
+              </a:rPr>
+              <a:t>Number of unique interarrival times: 73512 </a:t>
+            </a:r>
             <a:endParaRPr lang="en-US" dirty="0"/>
           </a:p>
           <a:p>
@@ -3949,13 +3976,22 @@
             </a:r>
           </a:p>
           <a:p>
-            <a:endParaRPr lang="en-US" dirty="0"/>
-          </a:p>
-          <a:p>
             <a:pPr marL="0" indent="0">
               <a:buNone/>
             </a:pPr>
-            <a:endParaRPr lang="en-US" dirty="0"/>
+            <a:r>
+              <a:rPr lang="en-US" dirty="0"/>
+              <a:t>first ten values for the cumulative hazard are: </a:t>
+            </a:r>
+          </a:p>
+          <a:p>
+            <a:pPr marL="0" indent="0">
+              <a:buNone/>
+            </a:pPr>
+            <a:r>
+              <a:rPr lang="en-US" dirty="0"/>
+              <a:t>[1.3603036197679321e-05, 	2.7206257440469614e-05, 4.080966373340536e-05,       	5.441325508152126e-05, 6.801703148985221e-05, 	8.162099296343331e-05, 9.522513950729989e-05, 	0.00010882947112648744, 0.0001224339878260317, 	0.00013603868961096856]</a:t>
+            </a:r>
           </a:p>
         </p:txBody>
       </p:sp>
@@ -3975,6 +4011,14 @@
 <file path=ppt/slides/slide6.xml><?xml version="1.0" encoding="utf-8"?>
 <p:sld xmlns:a="http://schemas.openxmlformats.org/drawingml/2006/main" xmlns:r="http://schemas.openxmlformats.org/officeDocument/2006/relationships" xmlns:p="http://schemas.openxmlformats.org/presentationml/2006/main">
   <p:cSld>
+    <p:bg>
+      <p:bgPr>
+        <a:solidFill>
+          <a:schemeClr val="bg1"/>
+        </a:solidFill>
+        <a:effectLst/>
+      </p:bgPr>
+    </p:bg>
     <p:spTree>
       <p:nvGrpSpPr>
         <p:cNvPr id="1" name="">
@@ -4011,13 +4055,20 @@
             <p:ph type="title"/>
           </p:nvPr>
         </p:nvSpPr>
-        <p:spPr/>
-        <p:txBody>
-          <a:bodyPr/>
-          <a:lstStyle/>
-          <a:p>
-            <a:r>
-              <a:rPr lang="en-US" dirty="0"/>
+        <p:spPr>
+          <a:xfrm>
+            <a:off x="561900" y="-466739"/>
+            <a:ext cx="3455821" cy="1616203"/>
+          </a:xfrm>
+        </p:spPr>
+        <p:txBody>
+          <a:bodyPr anchor="b">
+            <a:normAutofit/>
+          </a:bodyPr>
+          <a:lstStyle/>
+          <a:p>
+            <a:r>
+              <a:rPr lang="en-US" sz="3200" dirty="0"/>
               <a:t>Task 2</a:t>
             </a:r>
           </a:p>
@@ -4039,36 +4090,290 @@
             <p:ph idx="1"/>
           </p:nvPr>
         </p:nvSpPr>
-        <p:spPr/>
-        <p:txBody>
-          <a:bodyPr/>
-          <a:lstStyle/>
-          <a:p>
-            <a:r>
-              <a:rPr lang="en-US" dirty="0"/>
+        <p:spPr>
+          <a:xfrm>
+            <a:off x="507587" y="1439194"/>
+            <a:ext cx="4349226" cy="4766734"/>
+          </a:xfrm>
+        </p:spPr>
+        <p:txBody>
+          <a:bodyPr anchor="t">
+            <a:normAutofit fontScale="92500" lnSpcReduction="10000"/>
+          </a:bodyPr>
+          <a:lstStyle/>
+          <a:p>
+            <a:r>
+              <a:rPr lang="en-US" sz="2000" dirty="0"/>
               <a:t>Q5c: Plot the estimated cumulative hazard function. What can You conclude?</a:t>
             </a:r>
           </a:p>
           <a:p>
-            <a:endParaRPr lang="en-US" dirty="0"/>
-          </a:p>
-          <a:p>
-            <a:endParaRPr lang="en-US" dirty="0"/>
-          </a:p>
-          <a:p>
-            <a:r>
-              <a:rPr lang="en-US" dirty="0"/>
+            <a:pPr marL="0" indent="0">
+              <a:buNone/>
+            </a:pPr>
+            <a:r>
+              <a:rPr lang="en-US" sz="2000" dirty="0"/>
+              <a:t>The graph is approximately linear, it increases at a linear rate, and the cumulative hazard is predictable. Since the slope is also constant the instantaneous failure rate can be viewed as constant</a:t>
+            </a:r>
+          </a:p>
+          <a:p>
+            <a:endParaRPr lang="en-US" sz="2000" dirty="0"/>
+          </a:p>
+          <a:p>
+            <a:r>
+              <a:rPr lang="en-US" sz="2000" dirty="0"/>
               <a:t>Q5d: Is the system at the initial mortality, normal life, or wear-out period of its life?</a:t>
             </a:r>
           </a:p>
           <a:p>
-            <a:endParaRPr lang="en-US" dirty="0"/>
-          </a:p>
-          <a:p>
-            <a:endParaRPr lang="en-US" dirty="0"/>
-          </a:p>
-        </p:txBody>
-      </p:sp>
+            <a:pPr marL="0" indent="0">
+              <a:buNone/>
+            </a:pPr>
+            <a:r>
+              <a:rPr lang="en-US" sz="2000" dirty="0"/>
+              <a:t>The system is in the normal life period of its cycle. This is seen by the flat, linear section in the middle of the reliability curve.</a:t>
+            </a:r>
+          </a:p>
+          <a:p>
+            <a:pPr marL="0" indent="0">
+              <a:buNone/>
+            </a:pPr>
+            <a:endParaRPr lang="en-US" sz="2000" dirty="0"/>
+          </a:p>
+          <a:p>
+            <a:endParaRPr lang="en-US" sz="2000" dirty="0"/>
+          </a:p>
+          <a:p>
+            <a:endParaRPr lang="en-US" sz="2000" dirty="0"/>
+          </a:p>
+          <a:p>
+            <a:endParaRPr lang="en-US" sz="2000" dirty="0"/>
+          </a:p>
+        </p:txBody>
+      </p:sp>
+      <p:pic>
+        <p:nvPicPr>
+          <p:cNvPr id="1026" name="Picture 2" descr="A graph with a line going up&#10;&#10;Description automatically generated">
+            <a:extLst>
+              <a:ext uri="{FF2B5EF4-FFF2-40B4-BE49-F238E27FC236}">
+                <a16:creationId xmlns:a16="http://schemas.microsoft.com/office/drawing/2014/main" id="{A1FB1F21-D083-F25D-5F80-5DECB2814C3C}"/>
+              </a:ext>
+            </a:extLst>
+          </p:cNvPr>
+          <p:cNvPicPr>
+            <a:picLocks noChangeAspect="1" noChangeArrowheads="1"/>
+          </p:cNvPicPr>
+          <p:nvPr/>
+        </p:nvPicPr>
+        <p:blipFill>
+          <a:blip r:embed="rId2">
+            <a:extLst>
+              <a:ext uri="{28A0092B-C50C-407E-A947-70E740481C1C}">
+                <a14:useLocalDpi xmlns:a14="http://schemas.microsoft.com/office/drawing/2010/main" val="0"/>
+              </a:ext>
+            </a:extLst>
+          </a:blip>
+          <a:stretch>
+            <a:fillRect/>
+          </a:stretch>
+        </p:blipFill>
+        <p:spPr bwMode="auto">
+          <a:xfrm>
+            <a:off x="4987672" y="1149464"/>
+            <a:ext cx="6389346" cy="4568382"/>
+          </a:xfrm>
+          <a:prstGeom prst="rect">
+            <a:avLst/>
+          </a:prstGeom>
+          <a:noFill/>
+          <a:extLst>
+            <a:ext uri="{909E8E84-426E-40DD-AFC4-6F175D3DCCD1}">
+              <a14:hiddenFill xmlns:a14="http://schemas.microsoft.com/office/drawing/2010/main">
+                <a:solidFill>
+                  <a:srgbClr val="FFFFFF"/>
+                </a:solidFill>
+              </a14:hiddenFill>
+            </a:ext>
+          </a:extLst>
+        </p:spPr>
+      </p:pic>
+      <p:grpSp>
+        <p:nvGrpSpPr>
+          <p:cNvPr id="1031" name="Group 1030">
+            <a:extLst>
+              <a:ext uri="{FF2B5EF4-FFF2-40B4-BE49-F238E27FC236}">
+                <a16:creationId xmlns:a16="http://schemas.microsoft.com/office/drawing/2014/main" id="{6258F736-B256-8039-9DC6-F4E49A5C5AD5}"/>
+              </a:ext>
+              <a:ext uri="{C183D7F6-B498-43B3-948B-1728B52AA6E4}">
+                <adec:decorative xmlns:adec="http://schemas.microsoft.com/office/drawing/2017/decorative" val="1"/>
+              </a:ext>
+            </a:extLst>
+          </p:cNvPr>
+          <p:cNvGrpSpPr>
+            <a:grpSpLocks noGrp="1" noUngrp="1" noRot="1" noChangeAspect="1" noMove="1" noResize="1"/>
+          </p:cNvGrpSpPr>
+          <p:nvPr>
+            <p:extLst>
+              <p:ext uri="{386F3935-93C4-4BCD-93E2-E3B085C9AB24}">
+                <p16:designElem xmlns:p16="http://schemas.microsoft.com/office/powerpoint/2015/main" val="1"/>
+              </p:ext>
+            </p:extLst>
+          </p:nvPr>
+        </p:nvGrpSpPr>
+        <p:grpSpPr>
+          <a:xfrm flipH="1">
+            <a:off x="12068638" y="0"/>
+            <a:ext cx="123362" cy="6858000"/>
+            <a:chOff x="12068638" y="0"/>
+            <a:chExt cx="123362" cy="6858000"/>
+          </a:xfrm>
+        </p:grpSpPr>
+        <p:sp>
+          <p:nvSpPr>
+            <p:cNvPr id="1032" name="Rectangle 1031">
+              <a:extLst>
+                <a:ext uri="{FF2B5EF4-FFF2-40B4-BE49-F238E27FC236}">
+                  <a16:creationId xmlns:a16="http://schemas.microsoft.com/office/drawing/2014/main" id="{10B4520A-996E-330C-99DA-69CA4D89E906}"/>
+                </a:ext>
+                <a:ext uri="{C183D7F6-B498-43B3-948B-1728B52AA6E4}">
+                  <adec:decorative xmlns:adec="http://schemas.microsoft.com/office/drawing/2017/decorative" val="1"/>
+                </a:ext>
+              </a:extLst>
+            </p:cNvPr>
+            <p:cNvSpPr/>
+            <p:nvPr>
+              <p:extLst>
+                <p:ext uri="{386F3935-93C4-4BCD-93E2-E3B085C9AB24}">
+                  <p16:designElem xmlns:p16="http://schemas.microsoft.com/office/powerpoint/2015/main" val="1"/>
+                </p:ext>
+              </p:extLst>
+            </p:nvPr>
+          </p:nvSpPr>
+          <p:spPr>
+            <a:xfrm>
+              <a:off x="12068638" y="0"/>
+              <a:ext cx="123362" cy="6858000"/>
+            </a:xfrm>
+            <a:prstGeom prst="rect">
+              <a:avLst/>
+            </a:prstGeom>
+            <a:gradFill>
+              <a:gsLst>
+                <a:gs pos="0">
+                  <a:schemeClr val="accent2"/>
+                </a:gs>
+                <a:gs pos="100000">
+                  <a:schemeClr val="accent5"/>
+                </a:gs>
+              </a:gsLst>
+              <a:lin ang="1800000" scaled="0"/>
+            </a:gradFill>
+            <a:ln>
+              <a:noFill/>
+            </a:ln>
+          </p:spPr>
+          <p:style>
+            <a:lnRef idx="2">
+              <a:schemeClr val="accent1">
+                <a:shade val="50000"/>
+              </a:schemeClr>
+            </a:lnRef>
+            <a:fillRef idx="1">
+              <a:schemeClr val="accent1"/>
+            </a:fillRef>
+            <a:effectRef idx="0">
+              <a:schemeClr val="accent1"/>
+            </a:effectRef>
+            <a:fontRef idx="minor">
+              <a:schemeClr val="lt1"/>
+            </a:fontRef>
+          </p:style>
+          <p:txBody>
+            <a:bodyPr rtlCol="0" anchor="ctr"/>
+            <a:lstStyle/>
+            <a:p>
+              <a:pPr algn="ctr"/>
+              <a:endParaRPr lang="en-US"/>
+            </a:p>
+          </p:txBody>
+        </p:sp>
+        <p:sp>
+          <p:nvSpPr>
+            <p:cNvPr id="1033" name="Rectangle 1032">
+              <a:extLst>
+                <a:ext uri="{FF2B5EF4-FFF2-40B4-BE49-F238E27FC236}">
+                  <a16:creationId xmlns:a16="http://schemas.microsoft.com/office/drawing/2014/main" id="{EC8FA945-E356-695F-18D6-CAD4EF34FE4A}"/>
+                </a:ext>
+                <a:ext uri="{C183D7F6-B498-43B3-948B-1728B52AA6E4}">
+                  <adec:decorative xmlns:adec="http://schemas.microsoft.com/office/drawing/2017/decorative" val="1"/>
+                </a:ext>
+              </a:extLst>
+            </p:cNvPr>
+            <p:cNvSpPr/>
+            <p:nvPr>
+              <p:extLst>
+                <p:ext uri="{386F3935-93C4-4BCD-93E2-E3B085C9AB24}">
+                  <p16:designElem xmlns:p16="http://schemas.microsoft.com/office/powerpoint/2015/main" val="1"/>
+                </p:ext>
+              </p:extLst>
+            </p:nvPr>
+          </p:nvSpPr>
+          <p:spPr>
+            <a:xfrm>
+              <a:off x="12068638" y="3527553"/>
+              <a:ext cx="123362" cy="3330447"/>
+            </a:xfrm>
+            <a:prstGeom prst="rect">
+              <a:avLst/>
+            </a:prstGeom>
+            <a:gradFill>
+              <a:gsLst>
+                <a:gs pos="19000">
+                  <a:schemeClr val="accent5">
+                    <a:lumMod val="60000"/>
+                    <a:lumOff val="40000"/>
+                    <a:alpha val="0"/>
+                  </a:schemeClr>
+                </a:gs>
+                <a:gs pos="100000">
+                  <a:schemeClr val="accent5">
+                    <a:lumMod val="60000"/>
+                    <a:lumOff val="40000"/>
+                  </a:schemeClr>
+                </a:gs>
+              </a:gsLst>
+              <a:lin ang="600000" scaled="0"/>
+            </a:gradFill>
+            <a:ln>
+              <a:noFill/>
+            </a:ln>
+          </p:spPr>
+          <p:style>
+            <a:lnRef idx="2">
+              <a:schemeClr val="accent1">
+                <a:shade val="50000"/>
+              </a:schemeClr>
+            </a:lnRef>
+            <a:fillRef idx="1">
+              <a:schemeClr val="accent1"/>
+            </a:fillRef>
+            <a:effectRef idx="0">
+              <a:schemeClr val="accent1"/>
+            </a:effectRef>
+            <a:fontRef idx="minor">
+              <a:schemeClr val="lt1"/>
+            </a:fontRef>
+          </p:style>
+          <p:txBody>
+            <a:bodyPr rtlCol="0" anchor="ctr"/>
+            <a:lstStyle/>
+            <a:p>
+              <a:pPr algn="ctr"/>
+              <a:endParaRPr lang="en-US"/>
+            </a:p>
+          </p:txBody>
+        </p:sp>
+      </p:grpSp>
     </p:spTree>
     <p:extLst>
       <p:ext uri="{BB962C8B-B14F-4D97-AF65-F5344CB8AC3E}">
@@ -4151,7 +4456,9 @@
         </p:nvSpPr>
         <p:spPr/>
         <p:txBody>
-          <a:bodyPr/>
+          <a:bodyPr>
+            <a:normAutofit/>
+          </a:bodyPr>
           <a:lstStyle/>
           <a:p>
             <a:r>
@@ -4166,7 +4473,28 @@
             <a:endParaRPr lang="en-US" dirty="0"/>
           </a:p>
           <a:p>
+            <a:pPr marL="0" indent="0">
+              <a:buNone/>
+            </a:pPr>
+            <a:r>
+              <a:rPr lang="en-US" dirty="0"/>
+              <a:t>We can estimate the average hazard rate by taking the last point of the cumulative hazard rate (which the sum of all hazard rates) and dividing it by the max value of T over which those points were calculated.</a:t>
+            </a:r>
+          </a:p>
+          <a:p>
+            <a:pPr marL="0" indent="0">
+              <a:buNone/>
+            </a:pPr>
             <a:endParaRPr lang="en-US" dirty="0"/>
+          </a:p>
+          <a:p>
+            <a:pPr marL="0" indent="0">
+              <a:buNone/>
+            </a:pPr>
+            <a:r>
+              <a:rPr lang="en-US" dirty="0"/>
+              <a:t>Estimated average hazard rate = 0.0009236086705974977</a:t>
+            </a:r>
           </a:p>
           <a:p>
             <a:pPr marL="0" indent="0">
@@ -4198,6 +4526,14 @@
 <file path=ppt/slides/slide8.xml><?xml version="1.0" encoding="utf-8"?>
 <p:sld xmlns:a="http://schemas.openxmlformats.org/drawingml/2006/main" xmlns:r="http://schemas.openxmlformats.org/officeDocument/2006/relationships" xmlns:p="http://schemas.openxmlformats.org/presentationml/2006/main">
   <p:cSld>
+    <p:bg>
+      <p:bgPr>
+        <a:solidFill>
+          <a:schemeClr val="bg1"/>
+        </a:solidFill>
+        <a:effectLst/>
+      </p:bgPr>
+    </p:bg>
     <p:spTree>
       <p:nvGrpSpPr>
         <p:cNvPr id="1" name="">
@@ -4218,6 +4554,66 @@
           <a:chExt cx="0" cy="0"/>
         </a:xfrm>
       </p:grpSpPr>
+      <p:sp useBgFill="1">
+        <p:nvSpPr>
+          <p:cNvPr id="2055" name="Rectangle 2054">
+            <a:extLst>
+              <a:ext uri="{FF2B5EF4-FFF2-40B4-BE49-F238E27FC236}">
+                <a16:creationId xmlns:a16="http://schemas.microsoft.com/office/drawing/2014/main" id="{743AA782-23D1-4521-8CAD-47662984AA08}"/>
+              </a:ext>
+              <a:ext uri="{C183D7F6-B498-43B3-948B-1728B52AA6E4}">
+                <adec:decorative xmlns:adec="http://schemas.microsoft.com/office/drawing/2017/decorative" val="1"/>
+              </a:ext>
+            </a:extLst>
+          </p:cNvPr>
+          <p:cNvSpPr>
+            <a:spLocks noGrp="1" noRot="1" noChangeAspect="1" noMove="1" noResize="1" noEditPoints="1" noAdjustHandles="1" noChangeArrowheads="1" noChangeShapeType="1" noTextEdit="1"/>
+          </p:cNvSpPr>
+          <p:nvPr>
+            <p:extLst>
+              <p:ext uri="{386F3935-93C4-4BCD-93E2-E3B085C9AB24}">
+                <p16:designElem xmlns:p16="http://schemas.microsoft.com/office/powerpoint/2015/main" val="1"/>
+              </p:ext>
+            </p:extLst>
+          </p:nvPr>
+        </p:nvSpPr>
+        <p:spPr>
+          <a:xfrm>
+            <a:off x="0" y="0"/>
+            <a:ext cx="12192000" cy="6858000"/>
+          </a:xfrm>
+          <a:prstGeom prst="rect">
+            <a:avLst/>
+          </a:prstGeom>
+          <a:ln>
+            <a:noFill/>
+          </a:ln>
+        </p:spPr>
+        <p:style>
+          <a:lnRef idx="2">
+            <a:schemeClr val="accent1">
+              <a:shade val="50000"/>
+            </a:schemeClr>
+          </a:lnRef>
+          <a:fillRef idx="1">
+            <a:schemeClr val="accent1"/>
+          </a:fillRef>
+          <a:effectRef idx="0">
+            <a:schemeClr val="accent1"/>
+          </a:effectRef>
+          <a:fontRef idx="minor">
+            <a:schemeClr val="lt1"/>
+          </a:fontRef>
+        </p:style>
+        <p:txBody>
+          <a:bodyPr rtlCol="0" anchor="ctr"/>
+          <a:lstStyle/>
+          <a:p>
+            <a:pPr algn="ctr"/>
+            <a:endParaRPr lang="en-US"/>
+          </a:p>
+        </p:txBody>
+      </p:sp>
       <p:sp>
         <p:nvSpPr>
           <p:cNvPr id="2" name="Title 1">
@@ -4234,13 +4630,20 @@
             <p:ph type="title"/>
           </p:nvPr>
         </p:nvSpPr>
-        <p:spPr/>
-        <p:txBody>
-          <a:bodyPr/>
-          <a:lstStyle/>
-          <a:p>
-            <a:r>
-              <a:rPr lang="en-US" dirty="0"/>
+        <p:spPr>
+          <a:xfrm>
+            <a:off x="630936" y="325452"/>
+            <a:ext cx="4818888" cy="1481328"/>
+          </a:xfrm>
+        </p:spPr>
+        <p:txBody>
+          <a:bodyPr anchor="b">
+            <a:normAutofit/>
+          </a:bodyPr>
+          <a:lstStyle/>
+          <a:p>
+            <a:r>
+              <a:rPr lang="en-US" sz="5400" dirty="0"/>
               <a:t>Task 2</a:t>
             </a:r>
           </a:p>
@@ -4248,51 +4651,683 @@
       </p:sp>
       <p:sp>
         <p:nvSpPr>
-          <p:cNvPr id="3" name="Content Placeholder 2">
-            <a:extLst>
-              <a:ext uri="{FF2B5EF4-FFF2-40B4-BE49-F238E27FC236}">
-                <a16:creationId xmlns:a16="http://schemas.microsoft.com/office/drawing/2014/main" id="{6BD9CAEB-8A59-A5FA-E3E8-04405D468E5D}"/>
-              </a:ext>
-            </a:extLst>
-          </p:cNvPr>
-          <p:cNvSpPr>
-            <a:spLocks noGrp="1"/>
-          </p:cNvSpPr>
-          <p:nvPr>
-            <p:ph idx="1"/>
-          </p:nvPr>
-        </p:nvSpPr>
-        <p:spPr/>
-        <p:txBody>
-          <a:bodyPr/>
-          <a:lstStyle/>
-          <a:p>
-            <a:r>
-              <a:rPr lang="en-US" dirty="0"/>
-              <a:t>Q5f: Write down the theoretical cumulated hazard function and plot it on the same plot as Q5-c. </a:t>
-            </a:r>
-          </a:p>
-          <a:p>
-            <a:pPr marL="0" indent="0">
-              <a:buNone/>
-            </a:pPr>
-            <a:endParaRPr lang="en-US" dirty="0"/>
-          </a:p>
-          <a:p>
-            <a:r>
-              <a:rPr lang="en-US" dirty="0"/>
-              <a:t>Q5e: Compare the empirical hazard rate and cumulative hazard function with the theoretical ones. Are they consistent with each other? Why, or why not?</a:t>
-            </a:r>
-          </a:p>
-          <a:p>
-            <a:endParaRPr lang="en-US" dirty="0"/>
-          </a:p>
-        </p:txBody>
-      </p:sp>
+          <p:cNvPr id="2057" name="sketch line">
+            <a:extLst>
+              <a:ext uri="{FF2B5EF4-FFF2-40B4-BE49-F238E27FC236}">
+                <a16:creationId xmlns:a16="http://schemas.microsoft.com/office/drawing/2014/main" id="{71877DBC-BB60-40F0-AC93-2ACDBAAE60CE}"/>
+              </a:ext>
+              <a:ext uri="{C183D7F6-B498-43B3-948B-1728B52AA6E4}">
+                <adec:decorative xmlns:adec="http://schemas.microsoft.com/office/drawing/2017/decorative" val="1"/>
+              </a:ext>
+            </a:extLst>
+          </p:cNvPr>
+          <p:cNvSpPr>
+            <a:spLocks noGrp="1" noRot="1" noChangeAspect="1" noMove="1" noResize="1" noEditPoints="1" noAdjustHandles="1" noChangeArrowheads="1" noChangeShapeType="1" noTextEdit="1"/>
+          </p:cNvSpPr>
+          <p:nvPr>
+            <p:extLst>
+              <p:ext uri="{386F3935-93C4-4BCD-93E2-E3B085C9AB24}">
+                <p16:designElem xmlns:p16="http://schemas.microsoft.com/office/powerpoint/2015/main" val="1"/>
+              </p:ext>
+            </p:extLst>
+          </p:nvPr>
+        </p:nvSpPr>
+        <p:spPr>
+          <a:xfrm>
+            <a:off x="643278" y="2372868"/>
+            <a:ext cx="3255095" cy="18288"/>
+          </a:xfrm>
+          <a:custGeom>
+            <a:avLst/>
+            <a:gdLst>
+              <a:gd name="connsiteX0" fmla="*/ 0 w 3255095"/>
+              <a:gd name="connsiteY0" fmla="*/ 0 h 18288"/>
+              <a:gd name="connsiteX1" fmla="*/ 618468 w 3255095"/>
+              <a:gd name="connsiteY1" fmla="*/ 0 h 18288"/>
+              <a:gd name="connsiteX2" fmla="*/ 1269487 w 3255095"/>
+              <a:gd name="connsiteY2" fmla="*/ 0 h 18288"/>
+              <a:gd name="connsiteX3" fmla="*/ 1953057 w 3255095"/>
+              <a:gd name="connsiteY3" fmla="*/ 0 h 18288"/>
+              <a:gd name="connsiteX4" fmla="*/ 2636627 w 3255095"/>
+              <a:gd name="connsiteY4" fmla="*/ 0 h 18288"/>
+              <a:gd name="connsiteX5" fmla="*/ 3255095 w 3255095"/>
+              <a:gd name="connsiteY5" fmla="*/ 0 h 18288"/>
+              <a:gd name="connsiteX6" fmla="*/ 3255095 w 3255095"/>
+              <a:gd name="connsiteY6" fmla="*/ 18288 h 18288"/>
+              <a:gd name="connsiteX7" fmla="*/ 2538974 w 3255095"/>
+              <a:gd name="connsiteY7" fmla="*/ 18288 h 18288"/>
+              <a:gd name="connsiteX8" fmla="*/ 1822853 w 3255095"/>
+              <a:gd name="connsiteY8" fmla="*/ 18288 h 18288"/>
+              <a:gd name="connsiteX9" fmla="*/ 1171834 w 3255095"/>
+              <a:gd name="connsiteY9" fmla="*/ 18288 h 18288"/>
+              <a:gd name="connsiteX10" fmla="*/ 0 w 3255095"/>
+              <a:gd name="connsiteY10" fmla="*/ 18288 h 18288"/>
+              <a:gd name="connsiteX11" fmla="*/ 0 w 3255095"/>
+              <a:gd name="connsiteY11" fmla="*/ 0 h 18288"/>
+            </a:gdLst>
+            <a:ahLst/>
+            <a:cxnLst>
+              <a:cxn ang="0">
+                <a:pos x="connsiteX0" y="connsiteY0"/>
+              </a:cxn>
+              <a:cxn ang="0">
+                <a:pos x="connsiteX1" y="connsiteY1"/>
+              </a:cxn>
+              <a:cxn ang="0">
+                <a:pos x="connsiteX2" y="connsiteY2"/>
+              </a:cxn>
+              <a:cxn ang="0">
+                <a:pos x="connsiteX3" y="connsiteY3"/>
+              </a:cxn>
+              <a:cxn ang="0">
+                <a:pos x="connsiteX4" y="connsiteY4"/>
+              </a:cxn>
+              <a:cxn ang="0">
+                <a:pos x="connsiteX5" y="connsiteY5"/>
+              </a:cxn>
+              <a:cxn ang="0">
+                <a:pos x="connsiteX6" y="connsiteY6"/>
+              </a:cxn>
+              <a:cxn ang="0">
+                <a:pos x="connsiteX7" y="connsiteY7"/>
+              </a:cxn>
+              <a:cxn ang="0">
+                <a:pos x="connsiteX8" y="connsiteY8"/>
+              </a:cxn>
+              <a:cxn ang="0">
+                <a:pos x="connsiteX9" y="connsiteY9"/>
+              </a:cxn>
+              <a:cxn ang="0">
+                <a:pos x="connsiteX10" y="connsiteY10"/>
+              </a:cxn>
+              <a:cxn ang="0">
+                <a:pos x="connsiteX11" y="connsiteY11"/>
+              </a:cxn>
+            </a:cxnLst>
+            <a:rect l="l" t="t" r="r" b="b"/>
+            <a:pathLst>
+              <a:path w="3255095" h="18288" fill="none" extrusionOk="0">
+                <a:moveTo>
+                  <a:pt x="0" y="0"/>
+                </a:moveTo>
+                <a:cubicBezTo>
+                  <a:pt x="240201" y="-22123"/>
+                  <a:pt x="462021" y="-19623"/>
+                  <a:pt x="618468" y="0"/>
+                </a:cubicBezTo>
+                <a:cubicBezTo>
+                  <a:pt x="774915" y="19623"/>
+                  <a:pt x="974734" y="2035"/>
+                  <a:pt x="1269487" y="0"/>
+                </a:cubicBezTo>
+                <a:cubicBezTo>
+                  <a:pt x="1564240" y="-2035"/>
+                  <a:pt x="1733579" y="10639"/>
+                  <a:pt x="1953057" y="0"/>
+                </a:cubicBezTo>
+                <a:cubicBezTo>
+                  <a:pt x="2172535" y="-10639"/>
+                  <a:pt x="2453962" y="14018"/>
+                  <a:pt x="2636627" y="0"/>
+                </a:cubicBezTo>
+                <a:cubicBezTo>
+                  <a:pt x="2819292" y="-14018"/>
+                  <a:pt x="3121375" y="5399"/>
+                  <a:pt x="3255095" y="0"/>
+                </a:cubicBezTo>
+                <a:cubicBezTo>
+                  <a:pt x="3254386" y="8157"/>
+                  <a:pt x="3254682" y="12125"/>
+                  <a:pt x="3255095" y="18288"/>
+                </a:cubicBezTo>
+                <a:cubicBezTo>
+                  <a:pt x="3088545" y="23203"/>
+                  <a:pt x="2687475" y="7419"/>
+                  <a:pt x="2538974" y="18288"/>
+                </a:cubicBezTo>
+                <a:cubicBezTo>
+                  <a:pt x="2390473" y="29157"/>
+                  <a:pt x="2137381" y="-8959"/>
+                  <a:pt x="1822853" y="18288"/>
+                </a:cubicBezTo>
+                <a:cubicBezTo>
+                  <a:pt x="1508325" y="45535"/>
+                  <a:pt x="1466437" y="20385"/>
+                  <a:pt x="1171834" y="18288"/>
+                </a:cubicBezTo>
+                <a:cubicBezTo>
+                  <a:pt x="877231" y="16191"/>
+                  <a:pt x="561097" y="37643"/>
+                  <a:pt x="0" y="18288"/>
+                </a:cubicBezTo>
+                <a:cubicBezTo>
+                  <a:pt x="-46" y="12483"/>
+                  <a:pt x="-203" y="6491"/>
+                  <a:pt x="0" y="0"/>
+                </a:cubicBezTo>
+                <a:close/>
+              </a:path>
+              <a:path w="3255095" h="18288" stroke="0" extrusionOk="0">
+                <a:moveTo>
+                  <a:pt x="0" y="0"/>
+                </a:moveTo>
+                <a:cubicBezTo>
+                  <a:pt x="291965" y="19429"/>
+                  <a:pt x="363155" y="8568"/>
+                  <a:pt x="618468" y="0"/>
+                </a:cubicBezTo>
+                <a:cubicBezTo>
+                  <a:pt x="873781" y="-8568"/>
+                  <a:pt x="904459" y="-19505"/>
+                  <a:pt x="1171834" y="0"/>
+                </a:cubicBezTo>
+                <a:cubicBezTo>
+                  <a:pt x="1439209" y="19505"/>
+                  <a:pt x="1744369" y="9790"/>
+                  <a:pt x="1887955" y="0"/>
+                </a:cubicBezTo>
+                <a:cubicBezTo>
+                  <a:pt x="2031541" y="-9790"/>
+                  <a:pt x="2346378" y="21240"/>
+                  <a:pt x="2506423" y="0"/>
+                </a:cubicBezTo>
+                <a:cubicBezTo>
+                  <a:pt x="2666468" y="-21240"/>
+                  <a:pt x="2990257" y="30414"/>
+                  <a:pt x="3255095" y="0"/>
+                </a:cubicBezTo>
+                <a:cubicBezTo>
+                  <a:pt x="3254831" y="4493"/>
+                  <a:pt x="3255479" y="9472"/>
+                  <a:pt x="3255095" y="18288"/>
+                </a:cubicBezTo>
+                <a:cubicBezTo>
+                  <a:pt x="3120743" y="16690"/>
+                  <a:pt x="2759628" y="42462"/>
+                  <a:pt x="2604076" y="18288"/>
+                </a:cubicBezTo>
+                <a:cubicBezTo>
+                  <a:pt x="2448524" y="-5886"/>
+                  <a:pt x="2184336" y="19599"/>
+                  <a:pt x="1887955" y="18288"/>
+                </a:cubicBezTo>
+                <a:cubicBezTo>
+                  <a:pt x="1591574" y="16977"/>
+                  <a:pt x="1548845" y="6870"/>
+                  <a:pt x="1334589" y="18288"/>
+                </a:cubicBezTo>
+                <a:cubicBezTo>
+                  <a:pt x="1120333" y="29706"/>
+                  <a:pt x="996014" y="9662"/>
+                  <a:pt x="683570" y="18288"/>
+                </a:cubicBezTo>
+                <a:cubicBezTo>
+                  <a:pt x="371126" y="26914"/>
+                  <a:pt x="198687" y="16167"/>
+                  <a:pt x="0" y="18288"/>
+                </a:cubicBezTo>
+                <a:cubicBezTo>
+                  <a:pt x="843" y="9577"/>
+                  <a:pt x="371" y="6900"/>
+                  <a:pt x="0" y="0"/>
+                </a:cubicBezTo>
+                <a:close/>
+              </a:path>
+            </a:pathLst>
+          </a:custGeom>
+          <a:solidFill>
+            <a:schemeClr val="accent2"/>
+          </a:solidFill>
+          <a:ln w="38100" cap="rnd">
+            <a:solidFill>
+              <a:schemeClr val="accent2"/>
+            </a:solidFill>
+            <a:round/>
+            <a:extLst>
+              <a:ext uri="{C807C97D-BFC1-408E-A445-0C87EB9F89A2}">
+                <ask:lineSketchStyleProps xmlns:ask="http://schemas.microsoft.com/office/drawing/2018/sketchyshapes" sd="1219033472">
+                  <a:prstGeom prst="rect">
+                    <a:avLst/>
+                  </a:prstGeom>
+                  <ask:type>
+                    <ask:lineSketchFreehand/>
+                  </ask:type>
+                </ask:lineSketchStyleProps>
+              </a:ext>
+            </a:extLst>
+          </a:ln>
+        </p:spPr>
+        <p:style>
+          <a:lnRef idx="2">
+            <a:schemeClr val="accent1">
+              <a:shade val="50000"/>
+            </a:schemeClr>
+          </a:lnRef>
+          <a:fillRef idx="1">
+            <a:schemeClr val="accent1"/>
+          </a:fillRef>
+          <a:effectRef idx="0">
+            <a:schemeClr val="accent1"/>
+          </a:effectRef>
+          <a:fontRef idx="minor">
+            <a:schemeClr val="lt1"/>
+          </a:fontRef>
+        </p:style>
+        <p:txBody>
+          <a:bodyPr rtlCol="0" anchor="ctr"/>
+          <a:lstStyle/>
+          <a:p>
+            <a:pPr algn="ctr"/>
+            <a:endParaRPr lang="en-US"/>
+          </a:p>
+        </p:txBody>
+      </p:sp>
+      <mc:AlternateContent xmlns:mc="http://schemas.openxmlformats.org/markup-compatibility/2006" xmlns:a14="http://schemas.microsoft.com/office/drawing/2010/main">
+        <mc:Choice Requires="a14">
+          <p:sp>
+            <p:nvSpPr>
+              <p:cNvPr id="3" name="Content Placeholder 2">
+                <a:extLst>
+                  <a:ext uri="{FF2B5EF4-FFF2-40B4-BE49-F238E27FC236}">
+                    <a16:creationId xmlns:a16="http://schemas.microsoft.com/office/drawing/2014/main" id="{6BD9CAEB-8A59-A5FA-E3E8-04405D468E5D}"/>
+                  </a:ext>
+                </a:extLst>
+              </p:cNvPr>
+              <p:cNvSpPr>
+                <a:spLocks noGrp="1"/>
+              </p:cNvSpPr>
+              <p:nvPr>
+                <p:ph idx="1"/>
+              </p:nvPr>
+            </p:nvSpPr>
+            <p:spPr>
+              <a:xfrm>
+                <a:off x="5950712" y="96344"/>
+                <a:ext cx="6111240" cy="6418756"/>
+              </a:xfrm>
+            </p:spPr>
+            <p:txBody>
+              <a:bodyPr anchor="t">
+                <a:normAutofit lnSpcReduction="10000"/>
+              </a:bodyPr>
+              <a:lstStyle/>
+              <a:p>
+                <a:r>
+                  <a:rPr lang="en-US" sz="2200" dirty="0"/>
+                  <a:t>Q5f: Write down the theoretical cumulated hazard function and plot it on the same plot as Q5-c. </a:t>
+                </a:r>
+              </a:p>
+              <a:p>
+                <a:pPr marL="0" indent="0">
+                  <a:buNone/>
+                </a:pPr>
+                <a:r>
+                  <a:rPr lang="en-US" sz="2200" dirty="0"/>
+                  <a:t>Theoretical cumulative hazard  H(t) =  </a:t>
+                </a:r>
+                <a14:m>
+                  <m:oMath xmlns:m="http://schemas.openxmlformats.org/officeDocument/2006/math">
+                    <m:r>
+                      <a:rPr lang="en-US" sz="2200" b="0" i="1">
+                        <a:latin typeface="Cambria Math" panose="02040503050406030204" pitchFamily="18" charset="0"/>
+                      </a:rPr>
+                      <m:t>𝜆</m:t>
+                    </m:r>
+                  </m:oMath>
+                </a14:m>
+                <a:r>
+                  <a:rPr lang="en-US" sz="2200" dirty="0"/>
+                  <a:t>* t</a:t>
+                </a:r>
+              </a:p>
+              <a:p>
+                <a:r>
+                  <a:rPr lang="en-US" sz="2200" dirty="0"/>
+                  <a:t>Q5e: Compare the empirical hazard rate and cumulative hazard function with the theoretical ones. Are they consistent with each other? Why, or why not?</a:t>
+                </a:r>
+              </a:p>
+              <a:p>
+                <a:pPr marL="0" indent="0">
+                  <a:buNone/>
+                </a:pPr>
+                <a:r>
+                  <a:rPr lang="en-US" sz="2200" dirty="0"/>
+                  <a:t>We can observe from the graph that the empirical Nelson-</a:t>
+                </a:r>
+                <a:r>
+                  <a:rPr lang="en-US" sz="2200" dirty="0" err="1"/>
+                  <a:t>Aelen</a:t>
+                </a:r>
+                <a:r>
+                  <a:rPr lang="en-US" sz="2200" dirty="0"/>
+                  <a:t> estimated cumulative hazard function and the theoretical cumulative hazard function represented with </a:t>
+                </a:r>
+                <a:r>
+                  <a:rPr lang="en-US" sz="2200" dirty="0" err="1"/>
+                  <a:t>Th_Ht</a:t>
+                </a:r>
+                <a:r>
+                  <a:rPr lang="en-US" sz="2200" dirty="0"/>
+                  <a:t> are pretty consistent</a:t>
+                </a:r>
+              </a:p>
+              <a:p>
+                <a:pPr marL="0" indent="0">
+                  <a:buNone/>
+                </a:pPr>
+                <a:r>
+                  <a:rPr lang="en-US" sz="2200" dirty="0"/>
+                  <a:t>We can see this as the dotted line covers the solid curve almost perfectly till about the first half of the graph.</a:t>
+                </a:r>
+              </a:p>
+              <a:p>
+                <a:pPr marL="0" indent="0">
+                  <a:buNone/>
+                </a:pPr>
+                <a:r>
+                  <a:rPr lang="en-US" sz="2200" dirty="0"/>
+                  <a:t>After which it follows the trend of the solid curve fairly well.</a:t>
+                </a:r>
+              </a:p>
+              <a:p>
+                <a:pPr marL="0" indent="0">
+                  <a:buNone/>
+                </a:pPr>
+                <a:r>
+                  <a:rPr lang="en-US" sz="2200" dirty="0"/>
+                  <a:t>Overall conclusion - Consistent with each other</a:t>
+                </a:r>
+              </a:p>
+              <a:p>
+                <a:pPr marL="0" indent="0">
+                  <a:buNone/>
+                </a:pPr>
+                <a:endParaRPr lang="en-US" sz="2200" dirty="0"/>
+              </a:p>
+              <a:p>
+                <a:pPr marL="0" indent="0">
+                  <a:buNone/>
+                </a:pPr>
+                <a:endParaRPr lang="en-US" sz="2200" dirty="0"/>
+              </a:p>
+            </p:txBody>
+          </p:sp>
+        </mc:Choice>
+        <mc:Fallback xmlns="">
+          <p:sp>
+            <p:nvSpPr>
+              <p:cNvPr id="3" name="Content Placeholder 2">
+                <a:extLst>
+                  <a:ext uri="{FF2B5EF4-FFF2-40B4-BE49-F238E27FC236}">
+                    <a16:creationId xmlns:a16="http://schemas.microsoft.com/office/drawing/2014/main" id="{6BD9CAEB-8A59-A5FA-E3E8-04405D468E5D}"/>
+                  </a:ext>
+                </a:extLst>
+              </p:cNvPr>
+              <p:cNvSpPr>
+                <a:spLocks noGrp="1" noRot="1" noChangeAspect="1" noMove="1" noResize="1" noEditPoints="1" noAdjustHandles="1" noChangeArrowheads="1" noChangeShapeType="1" noTextEdit="1"/>
+              </p:cNvSpPr>
+              <p:nvPr>
+                <p:ph idx="1"/>
+              </p:nvPr>
+            </p:nvSpPr>
+            <p:spPr>
+              <a:xfrm>
+                <a:off x="5950712" y="96344"/>
+                <a:ext cx="6111240" cy="6418756"/>
+              </a:xfrm>
+              <a:blipFill>
+                <a:blip r:embed="rId2"/>
+                <a:stretch>
+                  <a:fillRect l="-1245" t="-1381" r="-1867"/>
+                </a:stretch>
+              </a:blipFill>
+            </p:spPr>
+            <p:txBody>
+              <a:bodyPr/>
+              <a:lstStyle/>
+              <a:p>
+                <a:r>
+                  <a:rPr lang="en-US">
+                    <a:noFill/>
+                  </a:rPr>
+                  <a:t> </a:t>
+                </a:r>
+              </a:p>
+            </p:txBody>
+          </p:sp>
+        </mc:Fallback>
+      </mc:AlternateContent>
+      <p:pic>
+        <p:nvPicPr>
+          <p:cNvPr id="2050" name="Picture 2">
+            <a:extLst>
+              <a:ext uri="{FF2B5EF4-FFF2-40B4-BE49-F238E27FC236}">
+                <a16:creationId xmlns:a16="http://schemas.microsoft.com/office/drawing/2014/main" id="{74D9BCD4-0EA1-9245-EDD1-121CB6CF5E71}"/>
+              </a:ext>
+            </a:extLst>
+          </p:cNvPr>
+          <p:cNvPicPr>
+            <a:picLocks noChangeAspect="1" noChangeArrowheads="1"/>
+          </p:cNvPicPr>
+          <p:nvPr/>
+        </p:nvPicPr>
+        <p:blipFill>
+          <a:blip r:embed="rId3">
+            <a:extLst>
+              <a:ext uri="{28A0092B-C50C-407E-A947-70E740481C1C}">
+                <a14:useLocalDpi xmlns:a14="http://schemas.microsoft.com/office/drawing/2010/main" val="0"/>
+              </a:ext>
+            </a:extLst>
+          </a:blip>
+          <a:stretch>
+            <a:fillRect/>
+          </a:stretch>
+        </p:blipFill>
+        <p:spPr bwMode="auto">
+          <a:xfrm>
+            <a:off x="130048" y="1806780"/>
+            <a:ext cx="5458968" cy="4053283"/>
+          </a:xfrm>
+          <a:prstGeom prst="rect">
+            <a:avLst/>
+          </a:prstGeom>
+          <a:noFill/>
+          <a:extLst>
+            <a:ext uri="{909E8E84-426E-40DD-AFC4-6F175D3DCCD1}">
+              <a14:hiddenFill xmlns:a14="http://schemas.microsoft.com/office/drawing/2010/main">
+                <a:solidFill>
+                  <a:srgbClr val="FFFFFF"/>
+                </a:solidFill>
+              </a14:hiddenFill>
+            </a:ext>
+          </a:extLst>
+        </p:spPr>
+      </p:pic>
     </p:spTree>
     <p:extLst>
       <p:ext uri="{BB962C8B-B14F-4D97-AF65-F5344CB8AC3E}">
         <p14:creationId xmlns:p14="http://schemas.microsoft.com/office/powerpoint/2010/main" val="2576594622"/>
+      </p:ext>
+    </p:extLst>
+  </p:cSld>
+  <p:clrMapOvr>
+    <a:masterClrMapping/>
+  </p:clrMapOvr>
+</p:sld>
+</file>
+
+<file path=ppt/slides/slide9.xml><?xml version="1.0" encoding="utf-8"?>
+<p:sld xmlns:a="http://schemas.openxmlformats.org/drawingml/2006/main" xmlns:r="http://schemas.openxmlformats.org/officeDocument/2006/relationships" xmlns:p="http://schemas.openxmlformats.org/presentationml/2006/main">
+  <p:cSld>
+    <p:spTree>
+      <p:nvGrpSpPr>
+        <p:cNvPr id="1" name=""/>
+        <p:cNvGrpSpPr/>
+        <p:nvPr/>
+      </p:nvGrpSpPr>
+      <p:grpSpPr>
+        <a:xfrm>
+          <a:off x="0" y="0"/>
+          <a:ext cx="0" cy="0"/>
+          <a:chOff x="0" y="0"/>
+          <a:chExt cx="0" cy="0"/>
+        </a:xfrm>
+      </p:grpSpPr>
+      <p:sp>
+        <p:nvSpPr>
+          <p:cNvPr id="2" name="Title 1">
+            <a:extLst>
+              <a:ext uri="{FF2B5EF4-FFF2-40B4-BE49-F238E27FC236}">
+                <a16:creationId xmlns:a16="http://schemas.microsoft.com/office/drawing/2014/main" id="{D52AB629-46AB-54E4-30B0-A01A21F9FF40}"/>
+              </a:ext>
+            </a:extLst>
+          </p:cNvPr>
+          <p:cNvSpPr>
+            <a:spLocks noGrp="1"/>
+          </p:cNvSpPr>
+          <p:nvPr>
+            <p:ph type="title"/>
+          </p:nvPr>
+        </p:nvSpPr>
+        <p:spPr/>
+        <p:txBody>
+          <a:bodyPr/>
+          <a:lstStyle/>
+          <a:p>
+            <a:r>
+              <a:rPr lang="en-US" dirty="0"/>
+              <a:t>Team Member Assessment</a:t>
+            </a:r>
+          </a:p>
+        </p:txBody>
+      </p:sp>
+      <p:sp>
+        <p:nvSpPr>
+          <p:cNvPr id="3" name="Content Placeholder 2">
+            <a:extLst>
+              <a:ext uri="{FF2B5EF4-FFF2-40B4-BE49-F238E27FC236}">
+                <a16:creationId xmlns:a16="http://schemas.microsoft.com/office/drawing/2014/main" id="{AA8887A7-EBAC-70AE-474C-34A8B73816D2}"/>
+              </a:ext>
+            </a:extLst>
+          </p:cNvPr>
+          <p:cNvSpPr>
+            <a:spLocks noGrp="1"/>
+          </p:cNvSpPr>
+          <p:nvPr>
+            <p:ph idx="1"/>
+          </p:nvPr>
+        </p:nvSpPr>
+        <p:spPr>
+          <a:xfrm>
+            <a:off x="838200" y="1470992"/>
+            <a:ext cx="10515600" cy="5247860"/>
+          </a:xfrm>
+        </p:spPr>
+        <p:txBody>
+          <a:bodyPr>
+            <a:normAutofit lnSpcReduction="10000"/>
+          </a:bodyPr>
+          <a:lstStyle/>
+          <a:p>
+            <a:pPr marL="0" indent="0">
+              <a:buNone/>
+            </a:pPr>
+            <a:r>
+              <a:rPr lang="en-US" dirty="0"/>
+              <a:t>Member 1 - Dhruv Vohra : </a:t>
+            </a:r>
+          </a:p>
+          <a:p>
+            <a:pPr marL="0" indent="0">
+              <a:buNone/>
+            </a:pPr>
+            <a:r>
+              <a:rPr lang="en-US" dirty="0"/>
+              <a:t>• Self Assessment – Worked on Task 2 parts 5 d, e, f, g</a:t>
+            </a:r>
+          </a:p>
+          <a:p>
+            <a:pPr marL="0" indent="0">
+              <a:buNone/>
+            </a:pPr>
+            <a:r>
+              <a:rPr lang="en-US" dirty="0"/>
+              <a:t>• Assessment of other team members – Brian and Vedaant finished their parts with great diligence and communicated very well. </a:t>
+            </a:r>
+          </a:p>
+          <a:p>
+            <a:pPr marL="0" indent="0">
+              <a:buNone/>
+            </a:pPr>
+            <a:r>
+              <a:rPr lang="en-US" dirty="0"/>
+              <a:t>Member 2 - Vedaant </a:t>
+            </a:r>
+            <a:r>
+              <a:rPr lang="en-US" dirty="0" err="1"/>
+              <a:t>Magow</a:t>
+            </a:r>
+            <a:r>
+              <a:rPr lang="en-US" dirty="0"/>
+              <a:t> : </a:t>
+            </a:r>
+          </a:p>
+          <a:p>
+            <a:pPr marL="0" indent="0">
+              <a:buNone/>
+            </a:pPr>
+            <a:r>
+              <a:rPr lang="en-US" dirty="0"/>
+              <a:t>• Self Assessment - Worked on Task 2 parts 5 a, </a:t>
+            </a:r>
+            <a:r>
+              <a:rPr lang="en-US" dirty="0" err="1"/>
+              <a:t>b,c</a:t>
+            </a:r>
+            <a:endParaRPr lang="en-US" dirty="0"/>
+          </a:p>
+          <a:p>
+            <a:pPr marL="0" indent="0">
+              <a:buNone/>
+            </a:pPr>
+            <a:r>
+              <a:rPr lang="en-US" dirty="0"/>
+              <a:t> • Assessment of other team members – Dhruv and Brian were great teammates. Good contribution and communication all around.</a:t>
+            </a:r>
+          </a:p>
+          <a:p>
+            <a:pPr marL="0" indent="0">
+              <a:buNone/>
+            </a:pPr>
+            <a:r>
+              <a:rPr lang="en-US" dirty="0"/>
+              <a:t>Member 3 - Brian Keating :</a:t>
+            </a:r>
+          </a:p>
+          <a:p>
+            <a:pPr marL="0" indent="0">
+              <a:buNone/>
+            </a:pPr>
+            <a:r>
+              <a:rPr lang="en-US" dirty="0"/>
+              <a:t>• Self Assessment - Task 2 part 1, 3, 4 </a:t>
+            </a:r>
+          </a:p>
+          <a:p>
+            <a:pPr marL="0" indent="0">
+              <a:buNone/>
+            </a:pPr>
+            <a:r>
+              <a:rPr lang="en-US" dirty="0"/>
+              <a:t>• Assessment of other team members – Dhruv and Vedaant finished their work and were good at communicating.</a:t>
+            </a:r>
+          </a:p>
+        </p:txBody>
+      </p:sp>
+    </p:spTree>
+    <p:extLst>
+      <p:ext uri="{BB962C8B-B14F-4D97-AF65-F5344CB8AC3E}">
+        <p14:creationId xmlns:p14="http://schemas.microsoft.com/office/powerpoint/2010/main" val="2935586127"/>
       </p:ext>
     </p:extLst>
   </p:cSld>
@@ -4618,6 +5653,14 @@
 </file>
 
 <file path=customXml/item1.xml><?xml version="1.0" encoding="utf-8"?>
+<p:properties xmlns:p="http://schemas.microsoft.com/office/2006/metadata/properties" xmlns:xsi="http://www.w3.org/2001/XMLSchema-instance" xmlns:pc="http://schemas.microsoft.com/office/infopath/2007/PartnerControls">
+  <documentManagement>
+    <_activity xmlns="26afeec6-c0f5-4eb1-a1c3-11e7e49adc3d" xsi:nil="true"/>
+  </documentManagement>
+</p:properties>
+</file>
+
+<file path=customXml/item2.xml><?xml version="1.0" encoding="utf-8"?>
 <ct:contentTypeSchema xmlns:ct="http://schemas.microsoft.com/office/2006/metadata/contentType" xmlns:ma="http://schemas.microsoft.com/office/2006/metadata/properties/metaAttributes" ct:_="" ma:_="" ma:contentTypeName="Document" ma:contentTypeID="0x0101004385B58923830E49944D5B019BDEBC39" ma:contentTypeVersion="12" ma:contentTypeDescription="Create a new document." ma:contentTypeScope="" ma:versionID="d4463c84f6102774bb81ed0ccdab41d6">
   <xsd:schema xmlns:xsd="http://www.w3.org/2001/XMLSchema" xmlns:xs="http://www.w3.org/2001/XMLSchema" xmlns:p="http://schemas.microsoft.com/office/2006/metadata/properties" xmlns:ns3="26afeec6-c0f5-4eb1-a1c3-11e7e49adc3d" targetNamespace="http://schemas.microsoft.com/office/2006/metadata/properties" ma:root="true" ma:fieldsID="eff7fdc48de9bab3f2dd713322ddd7e6" ns3:_="">
     <xsd:import namespace="26afeec6-c0f5-4eb1-a1c3-11e7e49adc3d"/>
@@ -4811,7 +5854,7 @@
 </ct:contentTypeSchema>
 </file>
 
-<file path=customXml/item2.xml><?xml version="1.0" encoding="utf-8"?>
+<file path=customXml/item3.xml><?xml version="1.0" encoding="utf-8"?>
 <?mso-contentType ?>
 <FormTemplates xmlns="http://schemas.microsoft.com/sharepoint/v3/contenttype/forms">
   <Display>DocumentLibraryForm</Display>
@@ -4820,15 +5863,23 @@
 </FormTemplates>
 </file>
 
-<file path=customXml/item3.xml><?xml version="1.0" encoding="utf-8"?>
-<p:properties xmlns:p="http://schemas.microsoft.com/office/2006/metadata/properties" xmlns:xsi="http://www.w3.org/2001/XMLSchema-instance" xmlns:pc="http://schemas.microsoft.com/office/infopath/2007/PartnerControls">
-  <documentManagement>
-    <_activity xmlns="26afeec6-c0f5-4eb1-a1c3-11e7e49adc3d" xsi:nil="true"/>
-  </documentManagement>
-</p:properties>
+<file path=customXml/itemProps1.xml><?xml version="1.0" encoding="utf-8"?>
+<ds:datastoreItem xmlns:ds="http://schemas.openxmlformats.org/officeDocument/2006/customXml" ds:itemID="{06AEF977-680A-4510-9878-785340C08A8E}">
+  <ds:schemaRefs>
+    <ds:schemaRef ds:uri="26afeec6-c0f5-4eb1-a1c3-11e7e49adc3d"/>
+    <ds:schemaRef ds:uri="http://schemas.microsoft.com/office/2006/documentManagement/types"/>
+    <ds:schemaRef ds:uri="http://purl.org/dc/terms/"/>
+    <ds:schemaRef ds:uri="http://schemas.openxmlformats.org/package/2006/metadata/core-properties"/>
+    <ds:schemaRef ds:uri="http://purl.org/dc/elements/1.1/"/>
+    <ds:schemaRef ds:uri="http://www.w3.org/XML/1998/namespace"/>
+    <ds:schemaRef ds:uri="http://schemas.microsoft.com/office/2006/metadata/properties"/>
+    <ds:schemaRef ds:uri="http://schemas.microsoft.com/office/infopath/2007/PartnerControls"/>
+    <ds:schemaRef ds:uri="http://purl.org/dc/dcmitype/"/>
+  </ds:schemaRefs>
+</ds:datastoreItem>
 </file>
 
-<file path=customXml/itemProps1.xml><?xml version="1.0" encoding="utf-8"?>
+<file path=customXml/itemProps2.xml><?xml version="1.0" encoding="utf-8"?>
 <ds:datastoreItem xmlns:ds="http://schemas.openxmlformats.org/officeDocument/2006/customXml" ds:itemID="{84F2F5C3-8BDB-4522-B0F8-A64B5F6016F8}">
   <ds:schemaRefs>
     <ds:schemaRef ds:uri="http://schemas.microsoft.com/office/2006/metadata/contentType"/>
@@ -4846,26 +5897,10 @@
 </ds:datastoreItem>
 </file>
 
-<file path=customXml/itemProps2.xml><?xml version="1.0" encoding="utf-8"?>
+<file path=customXml/itemProps3.xml><?xml version="1.0" encoding="utf-8"?>
 <ds:datastoreItem xmlns:ds="http://schemas.openxmlformats.org/officeDocument/2006/customXml" ds:itemID="{8BFA4120-6AF5-4D18-9039-F792E2148DB6}">
   <ds:schemaRefs>
     <ds:schemaRef ds:uri="http://schemas.microsoft.com/sharepoint/v3/contenttype/forms"/>
   </ds:schemaRefs>
 </ds:datastoreItem>
-</file>
-
-<file path=customXml/itemProps3.xml><?xml version="1.0" encoding="utf-8"?>
-<ds:datastoreItem xmlns:ds="http://schemas.openxmlformats.org/officeDocument/2006/customXml" ds:itemID="{06AEF977-680A-4510-9878-785340C08A8E}">
-  <ds:schemaRefs>
-    <ds:schemaRef ds:uri="26afeec6-c0f5-4eb1-a1c3-11e7e49adc3d"/>
-    <ds:schemaRef ds:uri="http://schemas.microsoft.com/office/2006/documentManagement/types"/>
-    <ds:schemaRef ds:uri="http://purl.org/dc/terms/"/>
-    <ds:schemaRef ds:uri="http://schemas.openxmlformats.org/package/2006/metadata/core-properties"/>
-    <ds:schemaRef ds:uri="http://purl.org/dc/elements/1.1/"/>
-    <ds:schemaRef ds:uri="http://www.w3.org/XML/1998/namespace"/>
-    <ds:schemaRef ds:uri="http://schemas.microsoft.com/office/2006/metadata/properties"/>
-    <ds:schemaRef ds:uri="http://schemas.microsoft.com/office/infopath/2007/PartnerControls"/>
-    <ds:schemaRef ds:uri="http://purl.org/dc/dcmitype/"/>
-  </ds:schemaRefs>
-</ds:datastoreItem>
 </file>
</xml_diff>

<commit_message>
Implement Task 4 Part 1 ML and MAP rules
</commit_message>
<xml_diff>
--- a/ece313_sp26_project_task_2.pptx
+++ b/ece313_sp26_project_task_2.pptx
@@ -3398,8 +3398,13 @@
           <a:p>
             <a:r>
               <a:rPr lang="en-US" dirty="0"/>
-              <a:t>&lt;dhruvv4 , vmagow2, bkeating2&gt;</a:t>
-            </a:r>
+              <a:t>&lt;dhruvv4 , vmagow2</a:t>
+            </a:r>
+            <a:r>
+              <a:rPr lang="en-US"/>
+              <a:t>, brianmk3&gt;</a:t>
+            </a:r>
+            <a:endParaRPr lang="en-US" dirty="0"/>
           </a:p>
           <a:p>
             <a:r>

</xml_diff>